<commit_message>
Adjust presentation slides to fix visual overlap issues
Update presentation file to resolve overlapping elements on slides 1 and 9.

Replit-Commit-Author: Agent
Replit-Commit-Session-Id: 85f09f3c-352d-446d-b98e-3f307c26fc5a
Replit-Commit-Checkpoint-Type: full_checkpoint
Replit-Commit-Event-Id: 6dfd6519-6d6d-4604-b2f2-fa41730cf899
Replit-Commit-Screenshot-Url: https://storage.googleapis.com/screenshot-production-us-central1/3bd53afc-ff4f-401b-9e3d-b367791ef629/85f09f3c-352d-446d-b98e-3f307c26fc5a/YVD5ZQp
Replit-Helium-Checkpoint-Created: true
</commit_message>
<xml_diff>
--- a/attached_assets/VaughnMartin-Investor-Deck-v11-final.pptx
+++ b/attached_assets/VaughnMartin-Investor-Deck-v11-final.pptx
@@ -4758,7 +4758,7 @@
         </p:nvSpPr>
         <p:spPr>
           <a:xfrm>
-            <a:off x="384048" y="4553712"/>
+            <a:off x="384048" y="4407408"/>
             <a:ext cx="5760720" cy="420624"/>
           </a:xfrm>
           <a:prstGeom prst="rect">
@@ -4804,7 +4804,7 @@
         </p:nvSpPr>
         <p:spPr>
           <a:xfrm>
-            <a:off x="493776" y="4642612"/>
+            <a:off x="493776" y="4496308"/>
             <a:ext cx="5577840" cy="365760"/>
           </a:xfrm>
           <a:prstGeom prst="rect">
@@ -4839,7 +4839,7 @@
         </p:nvSpPr>
         <p:spPr>
           <a:xfrm>
-            <a:off x="384048" y="5102352"/>
+            <a:off x="384048" y="4956048"/>
             <a:ext cx="5760720" cy="420624"/>
           </a:xfrm>
           <a:prstGeom prst="rect">
@@ -4885,7 +4885,7 @@
         </p:nvSpPr>
         <p:spPr>
           <a:xfrm>
-            <a:off x="493776" y="5191252"/>
+            <a:off x="493776" y="5044948"/>
             <a:ext cx="5577840" cy="365760"/>
           </a:xfrm>
           <a:prstGeom prst="rect">
@@ -4920,7 +4920,7 @@
         </p:nvSpPr>
         <p:spPr>
           <a:xfrm>
-            <a:off x="384048" y="5650992"/>
+            <a:off x="384048" y="5504688"/>
             <a:ext cx="5760720" cy="420624"/>
           </a:xfrm>
           <a:prstGeom prst="rect">
@@ -4966,7 +4966,7 @@
         </p:nvSpPr>
         <p:spPr>
           <a:xfrm>
-            <a:off x="493776" y="5739892"/>
+            <a:off x="493776" y="5593588"/>
             <a:ext cx="5577840" cy="365760"/>
           </a:xfrm>
           <a:prstGeom prst="rect">
@@ -18400,7 +18400,7 @@
         <p:spPr>
           <a:xfrm>
             <a:off x="128878" y="2633472"/>
-            <a:ext cx="5829809" cy="3529584"/>
+            <a:ext cx="5829809" cy="3166567"/>
           </a:xfrm>
           <a:prstGeom prst="rect">
             <a:avLst/>
@@ -18503,7 +18503,7 @@
         </p:nvSpPr>
         <p:spPr>
           <a:xfrm>
-            <a:off x="420624" y="5625427"/>
+            <a:off x="420624" y="5562295"/>
             <a:ext cx="5446623" cy="237744"/>
           </a:xfrm>
           <a:prstGeom prst="rect">
@@ -18548,7 +18548,7 @@
         <p:spPr>
           <a:xfrm>
             <a:off x="6233007" y="2633472"/>
-            <a:ext cx="5837073" cy="3511296"/>
+            <a:ext cx="5837073" cy="3166567"/>
           </a:xfrm>
           <a:prstGeom prst="rect">
             <a:avLst/>
@@ -18651,7 +18651,7 @@
         </p:nvSpPr>
         <p:spPr>
           <a:xfrm>
-            <a:off x="6324447" y="5625427"/>
+            <a:off x="6324447" y="5562295"/>
             <a:ext cx="5446623" cy="237744"/>
           </a:xfrm>
           <a:prstGeom prst="rect">

</xml_diff>

<commit_message>
Improve investor deck by closing identified gaps
Update investor deck PPTX by closing identified gaps in competitive landscape, evidence, and funding rationale.

Replit-Commit-Author: Agent
Replit-Commit-Session-Id: 85f09f3c-352d-446d-b98e-3f307c26fc5a
Replit-Commit-Checkpoint-Type: full_checkpoint
Replit-Commit-Event-Id: 88925925-2e7c-4a57-91d0-9fff180ea8d2
Replit-Commit-Screenshot-Url: https://storage.googleapis.com/screenshot-production-us-central1/3bd53afc-ff4f-401b-9e3d-b367791ef629/85f09f3c-352d-446d-b98e-3f307c26fc5a/YVD5ZQp
Replit-Helium-Checkpoint-Created: true
</commit_message>
<xml_diff>
--- a/attached_assets/VaughnMartin-Investor-Deck-v11-final.pptx
+++ b/attached_assets/VaughnMartin-Investor-Deck-v11-final.pptx
@@ -9574,6 +9574,41 @@
           </a:p>
         </p:txBody>
       </p:sp>
+      <p:sp>
+        <p:nvSpPr>
+          <p:cNvPr id="42" name="TextBox 41"/>
+          <p:cNvSpPr txBox="1"/>
+          <p:nvPr/>
+        </p:nvSpPr>
+        <p:spPr>
+          <a:xfrm>
+            <a:off x="594360" y="2798064"/>
+            <a:ext cx="10972800" cy="329184"/>
+          </a:xfrm>
+          <a:prstGeom prst="rect">
+            <a:avLst/>
+          </a:prstGeom>
+          <a:noFill/>
+        </p:spPr>
+        <p:txBody>
+          <a:bodyPr wrap="square">
+            <a:spAutoFit/>
+          </a:bodyPr>
+          <a:lstStyle/>
+          <a:p>
+            <a:pPr algn="l"/>
+            <a:r>
+              <a:rPr sz="1300" b="0" i="1">
+                <a:solidFill>
+                  <a:srgbClr val="C9A84C"/>
+                </a:solidFill>
+                <a:latin typeface="Barlow Condensed"/>
+              </a:rPr>
+              <a:t>6 Founding Partners × $75K = $450K revenue at M1 — GTM spend self-funds at milestone 1.</a:t>
+            </a:r>
+          </a:p>
+        </p:txBody>
+      </p:sp>
     </p:spTree>
   </p:cSld>
   <p:clrMapOvr>
@@ -14782,6 +14817,41 @@
                 <a:latin typeface="Calibri"/>
               </a:rPr>
               <a:t>06 / 13</a:t>
+            </a:r>
+          </a:p>
+        </p:txBody>
+      </p:sp>
+      <p:sp>
+        <p:nvSpPr>
+          <p:cNvPr id="25" name="TextBox 24"/>
+          <p:cNvSpPr txBox="1"/>
+          <p:nvPr/>
+        </p:nvSpPr>
+        <p:spPr>
+          <a:xfrm>
+            <a:off x="603504" y="4846320"/>
+            <a:ext cx="5358384" cy="310896"/>
+          </a:xfrm>
+          <a:prstGeom prst="rect">
+            <a:avLst/>
+          </a:prstGeom>
+          <a:noFill/>
+        </p:spPr>
+        <p:txBody>
+          <a:bodyPr wrap="square">
+            <a:spAutoFit/>
+          </a:bodyPr>
+          <a:lstStyle/>
+          <a:p>
+            <a:pPr algn="l"/>
+            <a:r>
+              <a:rPr sz="1100" b="0" i="1">
+                <a:solidFill>
+                  <a:srgbClr val="A0AAC0"/>
+                </a:solidFill>
+                <a:latin typeface="Barlow Condensed"/>
+              </a:rPr>
+              <a:t>e.g. Microsoft Copilot · ServiceNow · management consulting retainers</a:t>
             </a:r>
           </a:p>
         </p:txBody>

</xml_diff>